<commit_message>
Restyle deck with a boardroom color scheme
Executive navy and steel gray base, warm off-white content slides, a
single muted gold accent rule, restrained forest for pass stats and
muted red only for the bug card - consultant register instead of
security-vendor teal/coral. Still validates clean.

Co-authored-by: Adeyemi Folarin <devzephyr@users.noreply.github.com>
</commit_message>
<xml_diff>
--- a/devsecops/deliverables/DevSecOps_Slides.pptx
+++ b/devsecops/deliverables/DevSecOps_Slides.pptx
@@ -1595,7 +1595,7 @@
             <a:avLst/>
           </a:prstGeom>
           <a:solidFill>
-            <a:srgbClr val="21295C"/>
+            <a:srgbClr val="1F2A44"/>
           </a:solidFill>
           <a:ln/>
         </p:spPr>
@@ -1609,13 +1609,13 @@
         <p:spPr>
           <a:xfrm>
             <a:off x="0" y="4572000"/>
-            <a:ext cx="12192000" cy="82296"/>
-          </a:xfrm>
-          <a:prstGeom prst="rect">
-            <a:avLst/>
-          </a:prstGeom>
-          <a:solidFill>
-            <a:srgbClr val="1C7293"/>
+            <a:ext cx="12192000" cy="54864"/>
+          </a:xfrm>
+          <a:prstGeom prst="rect">
+            <a:avLst/>
+          </a:prstGeom>
+          <a:solidFill>
+            <a:srgbClr val="C9A227"/>
           </a:solidFill>
           <a:ln/>
         </p:spPr>
@@ -1647,7 +1647,7 @@
             <a:r>
               <a:rPr lang="en-US" sz="1600" spc="400" kern="0" dirty="0">
                 <a:solidFill>
-                  <a:srgbClr val="CADCFC"/>
+                  <a:srgbClr val="C9A227"/>
                 </a:solidFill>
               </a:rPr>
               <a:t>AUTOMATED CYBERSECURITY TESTING</a:t>
@@ -1719,7 +1719,7 @@
             <a:r>
               <a:rPr lang="en-US" sz="1600" dirty="0">
                 <a:solidFill>
-                  <a:srgbClr val="CADCFC"/>
+                  <a:srgbClr val="D8DCE4"/>
                 </a:solidFill>
               </a:rPr>
               <a:t>An on-premise security pipeline: OWASP WSTG-mapped tests, scanners, hardened deployment, DAST and developer notification</a:t>
@@ -1749,7 +1749,7 @@
           </a:solidFill>
           <a:ln w="25400">
             <a:solidFill>
-              <a:srgbClr val="00A896"/>
+              <a:srgbClr val="3A7D44"/>
             </a:solidFill>
             <a:prstDash val="solid"/>
           </a:ln>
@@ -1782,7 +1782,7 @@
             <a:r>
               <a:rPr lang="en-US" sz="3600" b="1" dirty="0">
                 <a:solidFill>
-                  <a:srgbClr val="00A896"/>
+                  <a:srgbClr val="3A7D44"/>
                 </a:solidFill>
               </a:rPr>
               <a:t>32</a:t>
@@ -1818,7 +1818,7 @@
             <a:r>
               <a:rPr lang="en-US" sz="1100" dirty="0">
                 <a:solidFill>
-                  <a:srgbClr val="1B2A41"/>
+                  <a:srgbClr val="232A33"/>
                 </a:solidFill>
               </a:rPr>
               <a:t>OWASP WSTG tests</a:t>
@@ -1848,7 +1848,7 @@
           </a:solidFill>
           <a:ln w="25400">
             <a:solidFill>
-              <a:srgbClr val="1C7293"/>
+              <a:srgbClr val="5D6B7A"/>
             </a:solidFill>
             <a:prstDash val="solid"/>
           </a:ln>
@@ -1881,7 +1881,7 @@
             <a:r>
               <a:rPr lang="en-US" sz="3600" b="1" dirty="0">
                 <a:solidFill>
-                  <a:srgbClr val="1C7293"/>
+                  <a:srgbClr val="5D6B7A"/>
                 </a:solidFill>
               </a:rPr>
               <a:t>5</a:t>
@@ -1917,7 +1917,7 @@
             <a:r>
               <a:rPr lang="en-US" sz="1100" dirty="0">
                 <a:solidFill>
-                  <a:srgbClr val="1B2A41"/>
+                  <a:srgbClr val="232A33"/>
                 </a:solidFill>
               </a:rPr>
               <a:t>pipeline stages</a:t>
@@ -1947,7 +1947,7 @@
           </a:solidFill>
           <a:ln w="25400">
             <a:solidFill>
-              <a:srgbClr val="F96167"/>
+              <a:srgbClr val="9E2B25"/>
             </a:solidFill>
             <a:prstDash val="solid"/>
           </a:ln>
@@ -1980,7 +1980,7 @@
             <a:r>
               <a:rPr lang="en-US" sz="3600" b="1" dirty="0">
                 <a:solidFill>
-                  <a:srgbClr val="F96167"/>
+                  <a:srgbClr val="9E2B25"/>
                 </a:solidFill>
               </a:rPr>
               <a:t>1</a:t>
@@ -2016,7 +2016,7 @@
             <a:r>
               <a:rPr lang="en-US" sz="1100" dirty="0">
                 <a:solidFill>
-                  <a:srgbClr val="1B2A41"/>
+                  <a:srgbClr val="232A33"/>
                 </a:solidFill>
               </a:rPr>
               <a:t>triaged security bug</a:t>
@@ -2115,7 +2115,7 @@
             <a:r>
               <a:rPr lang="en-US" sz="1100" dirty="0">
                 <a:solidFill>
-                  <a:srgbClr val="1B2A41"/>
+                  <a:srgbClr val="232A33"/>
                 </a:solidFill>
               </a:rPr>
               <a:t>cloud resources used</a:t>
@@ -2187,7 +2187,7 @@
             <a:r>
               <a:rPr lang="en-US" sz="1200" dirty="0">
                 <a:solidFill>
-                  <a:srgbClr val="CADCFC"/>
+                  <a:srgbClr val="D8DCE4"/>
                 </a:solidFill>
               </a:rPr>
               <a:t>Kimai - open-source time tracking (Symfony 6.4 / PHP, Doctrine, Twig, JSON API)</a:t>
@@ -2236,7 +2236,7 @@
             <a:avLst/>
           </a:prstGeom>
           <a:solidFill>
-            <a:srgbClr val="F4F7FB"/>
+            <a:srgbClr val="F6F6F3"/>
           </a:solidFill>
           <a:ln/>
         </p:spPr>
@@ -2256,7 +2256,7 @@
             <a:avLst/>
           </a:prstGeom>
           <a:solidFill>
-            <a:srgbClr val="065A82"/>
+            <a:srgbClr val="33415C"/>
           </a:solidFill>
           <a:ln/>
         </p:spPr>
@@ -2270,13 +2270,13 @@
         <p:spPr>
           <a:xfrm>
             <a:off x="0" y="1051560"/>
-            <a:ext cx="12192000" cy="64008"/>
-          </a:xfrm>
-          <a:prstGeom prst="rect">
-            <a:avLst/>
-          </a:prstGeom>
-          <a:solidFill>
-            <a:srgbClr val="1C7293"/>
+            <a:ext cx="12192000" cy="45720"/>
+          </a:xfrm>
+          <a:prstGeom prst="rect">
+            <a:avLst/>
+          </a:prstGeom>
+          <a:solidFill>
+            <a:srgbClr val="C9A227"/>
           </a:solidFill>
           <a:ln/>
         </p:spPr>
@@ -2344,7 +2344,7 @@
             <a:r>
               <a:rPr lang="en-US" sz="1200" dirty="0">
                 <a:solidFill>
-                  <a:srgbClr val="CADCFC"/>
+                  <a:srgbClr val="D8DCE4"/>
                 </a:solidFill>
               </a:rPr>
               <a:t>GitHub Actions on a self-hosted runner - no cloud deployment</a:t>
@@ -2370,7 +2370,7 @@
             </a:avLst>
           </a:prstGeom>
           <a:solidFill>
-            <a:srgbClr val="065A82"/>
+            <a:srgbClr val="33415C"/>
           </a:solidFill>
           <a:ln/>
         </p:spPr>
@@ -2438,7 +2438,7 @@
             <a:r>
               <a:rPr lang="en-US" sz="950" dirty="0">
                 <a:solidFill>
-                  <a:srgbClr val="CADCFC"/>
+                  <a:srgbClr val="D8DCE4"/>
                 </a:solidFill>
               </a:rPr>
               <a:t>PHPStan L9 | PhpCsFixer | Semgrep (gating + audit) | SonarQube*</a:t>
@@ -2462,7 +2462,7 @@
             <a:avLst/>
           </a:prstGeom>
           <a:solidFill>
-            <a:srgbClr val="1C7293"/>
+            <a:srgbClr val="5D6B7A"/>
           </a:solidFill>
           <a:ln/>
         </p:spPr>
@@ -2484,7 +2484,7 @@
             </a:avLst>
           </a:prstGeom>
           <a:solidFill>
-            <a:srgbClr val="065A82"/>
+            <a:srgbClr val="33415C"/>
           </a:solidFill>
           <a:ln/>
         </p:spPr>
@@ -2552,7 +2552,7 @@
             <a:r>
               <a:rPr lang="en-US" sz="950" dirty="0">
                 <a:solidFill>
-                  <a:srgbClr val="CADCFC"/>
+                  <a:srgbClr val="D8DCE4"/>
                 </a:solidFill>
               </a:rPr>
               <a:t>composer audit | pnpm audit | Trivy | Dependency-Check</a:t>
@@ -2576,7 +2576,7 @@
             <a:avLst/>
           </a:prstGeom>
           <a:solidFill>
-            <a:srgbClr val="1C7293"/>
+            <a:srgbClr val="5D6B7A"/>
           </a:solidFill>
           <a:ln/>
         </p:spPr>
@@ -2598,7 +2598,7 @@
             </a:avLst>
           </a:prstGeom>
           <a:solidFill>
-            <a:srgbClr val="065A82"/>
+            <a:srgbClr val="33415C"/>
           </a:solidFill>
           <a:ln/>
         </p:spPr>
@@ -2666,7 +2666,7 @@
             <a:r>
               <a:rPr lang="en-US" sz="950" dirty="0">
                 <a:solidFill>
-                  <a:srgbClr val="CADCFC"/>
+                  <a:srgbClr val="D8DCE4"/>
                 </a:solidFill>
               </a:rPr>
               <a:t>32 OWASP WSTG tests + existing security suites (MariaDB svc)</a:t>
@@ -2690,7 +2690,7 @@
             <a:avLst/>
           </a:prstGeom>
           <a:solidFill>
-            <a:srgbClr val="1C7293"/>
+            <a:srgbClr val="5D6B7A"/>
           </a:solidFill>
           <a:ln/>
         </p:spPr>
@@ -2712,7 +2712,7 @@
             </a:avLst>
           </a:prstGeom>
           <a:solidFill>
-            <a:srgbClr val="065A82"/>
+            <a:srgbClr val="33415C"/>
           </a:solidFill>
           <a:ln/>
         </p:spPr>
@@ -2780,7 +2780,7 @@
             <a:r>
               <a:rPr lang="en-US" sz="950" dirty="0">
                 <a:solidFill>
-                  <a:srgbClr val="CADCFC"/>
+                  <a:srgbClr val="D8DCE4"/>
                 </a:solidFill>
               </a:rPr>
               <a:t>hardened build | compose | Trivy image | smoke | audit | ZAP</a:t>
@@ -2804,7 +2804,7 @@
             <a:avLst/>
           </a:prstGeom>
           <a:solidFill>
-            <a:srgbClr val="1C7293"/>
+            <a:srgbClr val="5D6B7A"/>
           </a:solidFill>
           <a:ln/>
         </p:spPr>
@@ -2826,7 +2826,7 @@
             </a:avLst>
           </a:prstGeom>
           <a:solidFill>
-            <a:srgbClr val="065A82"/>
+            <a:srgbClr val="33415C"/>
           </a:solidFill>
           <a:ln/>
         </p:spPr>
@@ -2894,7 +2894,7 @@
             <a:r>
               <a:rPr lang="en-US" sz="950" dirty="0">
                 <a:solidFill>
-                  <a:srgbClr val="CADCFC"/>
+                  <a:srgbClr val="D8DCE4"/>
                 </a:solidFill>
               </a:rPr>
               <a:t>de-duplicated GitHub issue + optional webhook</a:t>
@@ -2930,7 +2930,7 @@
             <a:r>
               <a:rPr lang="en-US" sz="1200" dirty="0">
                 <a:solidFill>
-                  <a:srgbClr val="1B2A41"/>
+                  <a:srgbClr val="232A33"/>
                 </a:solidFill>
               </a:rPr>
               <a:t>Concurrency-controlled, actions pinned by SHA, zizmor-scanned</a:t>
@@ -2954,13 +2954,13 @@
             <a:avLst/>
           </a:prstGeom>
           <a:solidFill>
-            <a:srgbClr val="CADCFC">
+            <a:srgbClr val="D8DCE4">
               <a:alpha val="45000"/>
             </a:srgbClr>
           </a:solidFill>
           <a:ln w="12700">
             <a:solidFill>
-              <a:srgbClr val="065A82"/>
+              <a:srgbClr val="33415C"/>
             </a:solidFill>
             <a:prstDash val="dash"/>
           </a:ln>
@@ -2993,7 +2993,7 @@
             <a:r>
               <a:rPr lang="en-US" sz="1000" i="1" dirty="0">
                 <a:solidFill>
-                  <a:srgbClr val="065A82"/>
+                  <a:srgbClr val="33415C"/>
                 </a:solidFill>
               </a:rPr>
               <a:t>[insert screenshot 1: green end-to-end run with all stages]</a:t>
@@ -3042,7 +3042,7 @@
             <a:avLst/>
           </a:prstGeom>
           <a:solidFill>
-            <a:srgbClr val="F4F7FB"/>
+            <a:srgbClr val="F6F6F3"/>
           </a:solidFill>
           <a:ln/>
         </p:spPr>
@@ -3062,7 +3062,7 @@
             <a:avLst/>
           </a:prstGeom>
           <a:solidFill>
-            <a:srgbClr val="065A82"/>
+            <a:srgbClr val="33415C"/>
           </a:solidFill>
           <a:ln/>
         </p:spPr>
@@ -3076,13 +3076,13 @@
         <p:spPr>
           <a:xfrm>
             <a:off x="0" y="1051560"/>
-            <a:ext cx="12192000" cy="64008"/>
-          </a:xfrm>
-          <a:prstGeom prst="rect">
-            <a:avLst/>
-          </a:prstGeom>
-          <a:solidFill>
-            <a:srgbClr val="1C7293"/>
+            <a:ext cx="12192000" cy="45720"/>
+          </a:xfrm>
+          <a:prstGeom prst="rect">
+            <a:avLst/>
+          </a:prstGeom>
+          <a:solidFill>
+            <a:srgbClr val="C9A227"/>
           </a:solidFill>
           <a:ln/>
         </p:spPr>
@@ -3150,7 +3150,7 @@
             <a:r>
               <a:rPr lang="en-US" sz="1200" dirty="0">
                 <a:solidFill>
-                  <a:srgbClr val="CADCFC"/>
+                  <a:srgbClr val="D8DCE4"/>
                 </a:solidFill>
               </a:rPr>
               <a:t>32 automated tests in tests/SecurityTesting/ (--group security)</a:t>
@@ -3180,7 +3180,7 @@
           </a:solidFill>
           <a:ln w="19050">
             <a:solidFill>
-              <a:srgbClr val="1C7293"/>
+              <a:srgbClr val="5D6B7A"/>
             </a:solidFill>
             <a:prstDash val="solid"/>
           </a:ln>
@@ -3213,7 +3213,7 @@
             <a:r>
               <a:rPr lang="en-US" sz="1400" b="1" dirty="0">
                 <a:solidFill>
-                  <a:srgbClr val="065A82"/>
+                  <a:srgbClr val="33415C"/>
                 </a:solidFill>
               </a:rPr>
               <a:t>4.4 ATHN</a:t>
@@ -3253,7 +3253,7 @@
             <a:r>
               <a:rPr lang="en-US" sz="1050" dirty="0">
                 <a:solidFill>
-                  <a:srgbClr val="1B2A41"/>
+                  <a:srgbClr val="232A33"/>
                 </a:solidFill>
               </a:rPr>
               <a:t>401 without credentials</a:t>
@@ -3271,7 +3271,7 @@
             <a:r>
               <a:rPr lang="en-US" sz="1050" dirty="0">
                 <a:solidFill>
-                  <a:srgbClr val="1B2A41"/>
+                  <a:srgbClr val="232A33"/>
                 </a:solidFill>
               </a:rPr>
               <a:t>invalid token: no info leak</a:t>
@@ -3289,7 +3289,7 @@
             <a:r>
               <a:rPr lang="en-US" sz="1050" dirty="0">
                 <a:solidFill>
-                  <a:srgbClr val="1B2A41"/>
+                  <a:srgbClr val="232A33"/>
                 </a:solidFill>
               </a:rPr>
               <a:t>disabled account blocked</a:t>
@@ -3319,7 +3319,7 @@
           </a:solidFill>
           <a:ln w="19050">
             <a:solidFill>
-              <a:srgbClr val="1C7293"/>
+              <a:srgbClr val="5D6B7A"/>
             </a:solidFill>
             <a:prstDash val="solid"/>
           </a:ln>
@@ -3352,7 +3352,7 @@
             <a:r>
               <a:rPr lang="en-US" sz="1400" b="1" dirty="0">
                 <a:solidFill>
-                  <a:srgbClr val="065A82"/>
+                  <a:srgbClr val="33415C"/>
                 </a:solidFill>
               </a:rPr>
               <a:t>4.5 ATHZ</a:t>
@@ -3392,7 +3392,7 @@
             <a:r>
               <a:rPr lang="en-US" sz="1050" dirty="0">
                 <a:solidFill>
-                  <a:srgbClr val="1B2A41"/>
+                  <a:srgbClr val="232A33"/>
                 </a:solidFill>
               </a:rPr>
               <a:t>IDOR read + modify denied</a:t>
@@ -3410,7 +3410,7 @@
             <a:r>
               <a:rPr lang="en-US" sz="1050" dirty="0">
                 <a:solidFill>
-                  <a:srgbClr val="1B2A41"/>
+                  <a:srgbClr val="232A33"/>
                 </a:solidFill>
               </a:rPr>
               <a:t>foreign profile denied</a:t>
@@ -3428,7 +3428,7 @@
             <a:r>
               <a:rPr lang="en-US" sz="1050" dirty="0">
                 <a:solidFill>
-                  <a:srgbClr val="1B2A41"/>
+                  <a:srgbClr val="232A33"/>
                 </a:solidFill>
               </a:rPr>
               <a:t>no privilege escalation</a:t>
@@ -3458,7 +3458,7 @@
           </a:solidFill>
           <a:ln w="19050">
             <a:solidFill>
-              <a:srgbClr val="1C7293"/>
+              <a:srgbClr val="5D6B7A"/>
             </a:solidFill>
             <a:prstDash val="solid"/>
           </a:ln>
@@ -3491,7 +3491,7 @@
             <a:r>
               <a:rPr lang="en-US" sz="1400" b="1" dirty="0">
                 <a:solidFill>
-                  <a:srgbClr val="065A82"/>
+                  <a:srgbClr val="33415C"/>
                 </a:solidFill>
               </a:rPr>
               <a:t>4.6 SESS</a:t>
@@ -3531,7 +3531,7 @@
             <a:r>
               <a:rPr lang="en-US" sz="1050" dirty="0">
                 <a:solidFill>
-                  <a:srgbClr val="1B2A41"/>
+                  <a:srgbClr val="232A33"/>
                 </a:solidFill>
               </a:rPr>
               <a:t>HttpOnly + SameSite=Lax</a:t>
@@ -3549,7 +3549,7 @@
             <a:r>
               <a:rPr lang="en-US" sz="1050" dirty="0">
                 <a:solidFill>
-                  <a:srgbClr val="1B2A41"/>
+                  <a:srgbClr val="232A33"/>
                 </a:solidFill>
               </a:rPr>
               <a:t>Secure flag behavior</a:t>
@@ -3567,7 +3567,7 @@
             <a:r>
               <a:rPr lang="en-US" sz="1050" dirty="0">
                 <a:solidFill>
-                  <a:srgbClr val="1B2A41"/>
+                  <a:srgbClr val="232A33"/>
                 </a:solidFill>
               </a:rPr>
               <a:t>cookie_secure=auto</a:t>
@@ -3597,7 +3597,7 @@
           </a:solidFill>
           <a:ln w="19050">
             <a:solidFill>
-              <a:srgbClr val="1C7293"/>
+              <a:srgbClr val="5D6B7A"/>
             </a:solidFill>
             <a:prstDash val="solid"/>
           </a:ln>
@@ -3630,7 +3630,7 @@
             <a:r>
               <a:rPr lang="en-US" sz="1400" b="1" dirty="0">
                 <a:solidFill>
-                  <a:srgbClr val="065A82"/>
+                  <a:srgbClr val="33415C"/>
                 </a:solidFill>
               </a:rPr>
               <a:t>4.7 INPV</a:t>
@@ -3670,7 +3670,7 @@
             <a:r>
               <a:rPr lang="en-US" sz="1050" dirty="0">
                 <a:solidFill>
-                  <a:srgbClr val="1B2A41"/>
+                  <a:srgbClr val="232A33"/>
                 </a:solidFill>
               </a:rPr>
               <a:t>SQLi on 6 API endpoints</a:t>
@@ -3688,7 +3688,7 @@
             <a:r>
               <a:rPr lang="en-US" sz="1050" dirty="0">
                 <a:solidFill>
-                  <a:srgbClr val="1B2A41"/>
+                  <a:srgbClr val="232A33"/>
                 </a:solidFill>
               </a:rPr>
               <a:t>payloads stored inertly</a:t>
@@ -3706,7 +3706,7 @@
             <a:r>
               <a:rPr lang="en-US" sz="1050" dirty="0">
                 <a:solidFill>
-                  <a:srgbClr val="1B2A41"/>
+                  <a:srgbClr val="232A33"/>
                 </a:solidFill>
               </a:rPr>
               <a:t>stored XSS escaped</a:t>
@@ -3736,7 +3736,7 @@
           </a:solidFill>
           <a:ln w="19050">
             <a:solidFill>
-              <a:srgbClr val="1C7293"/>
+              <a:srgbClr val="5D6B7A"/>
             </a:solidFill>
             <a:prstDash val="solid"/>
           </a:ln>
@@ -3769,7 +3769,7 @@
             <a:r>
               <a:rPr lang="en-US" sz="1400" b="1" dirty="0">
                 <a:solidFill>
-                  <a:srgbClr val="065A82"/>
+                  <a:srgbClr val="33415C"/>
                 </a:solidFill>
               </a:rPr>
               <a:t>4.8 ERRH</a:t>
@@ -3809,7 +3809,7 @@
             <a:r>
               <a:rPr lang="en-US" sz="1050" dirty="0">
                 <a:solidFill>
-                  <a:srgbClr val="1B2A41"/>
+                  <a:srgbClr val="232A33"/>
                 </a:solidFill>
               </a:rPr>
               <a:t>minimal 401/404 bodies</a:t>
@@ -3827,7 +3827,7 @@
             <a:r>
               <a:rPr lang="en-US" sz="1050" dirty="0">
                 <a:solidFill>
-                  <a:srgbClr val="1B2A41"/>
+                  <a:srgbClr val="232A33"/>
                 </a:solidFill>
               </a:rPr>
               <a:t>no stack traces</a:t>
@@ -3845,7 +3845,7 @@
             <a:r>
               <a:rPr lang="en-US" sz="1050" dirty="0">
                 <a:solidFill>
-                  <a:srgbClr val="1B2A41"/>
+                  <a:srgbClr val="232A33"/>
                 </a:solidFill>
               </a:rPr>
               <a:t>no debug routes</a:t>
@@ -3875,7 +3875,7 @@
           </a:solidFill>
           <a:ln w="19050">
             <a:solidFill>
-              <a:srgbClr val="1C7293"/>
+              <a:srgbClr val="5D6B7A"/>
             </a:solidFill>
             <a:prstDash val="solid"/>
           </a:ln>
@@ -3908,7 +3908,7 @@
             <a:r>
               <a:rPr lang="en-US" sz="1400" b="1" dirty="0">
                 <a:solidFill>
-                  <a:srgbClr val="065A82"/>
+                  <a:srgbClr val="33415C"/>
                 </a:solidFill>
               </a:rPr>
               <a:t>4.2 CONF</a:t>
@@ -3948,7 +3948,7 @@
             <a:r>
               <a:rPr lang="en-US" sz="1050" dirty="0">
                 <a:solidFill>
-                  <a:srgbClr val="1B2A41"/>
+                  <a:srgbClr val="232A33"/>
                 </a:solidFill>
               </a:rPr>
               <a:t>login throttling on</a:t>
@@ -3966,7 +3966,7 @@
             <a:r>
               <a:rPr lang="en-US" sz="1050" dirty="0">
                 <a:solidFill>
-                  <a:srgbClr val="1B2A41"/>
+                  <a:srgbClr val="232A33"/>
                 </a:solidFill>
               </a:rPr>
               <a:t>login CSRF on</a:t>
@@ -3984,7 +3984,7 @@
             <a:r>
               <a:rPr lang="en-US" sz="1050" dirty="0">
                 <a:solidFill>
-                  <a:srgbClr val="1B2A41"/>
+                  <a:srgbClr val="232A33"/>
                 </a:solidFill>
               </a:rPr>
               <a:t>APP_DEBUG=0</a:t>
@@ -4008,13 +4008,13 @@
             <a:avLst/>
           </a:prstGeom>
           <a:solidFill>
-            <a:srgbClr val="CADCFC">
+            <a:srgbClr val="D8DCE4">
               <a:alpha val="45000"/>
             </a:srgbClr>
           </a:solidFill>
           <a:ln w="12700">
             <a:solidFill>
-              <a:srgbClr val="065A82"/>
+              <a:srgbClr val="33415C"/>
             </a:solidFill>
             <a:prstDash val="dash"/>
           </a:ln>
@@ -4047,7 +4047,7 @@
             <a:r>
               <a:rPr lang="en-US" sz="1000" i="1" dirty="0">
                 <a:solidFill>
-                  <a:srgbClr val="065A82"/>
+                  <a:srgbClr val="33415C"/>
                 </a:solidFill>
               </a:rPr>
               <a:t>[insert: phpunit OK (32 tests)]</a:t>
@@ -4096,7 +4096,7 @@
             <a:avLst/>
           </a:prstGeom>
           <a:solidFill>
-            <a:srgbClr val="F4F7FB"/>
+            <a:srgbClr val="F6F6F3"/>
           </a:solidFill>
           <a:ln/>
         </p:spPr>
@@ -4116,7 +4116,7 @@
             <a:avLst/>
           </a:prstGeom>
           <a:solidFill>
-            <a:srgbClr val="065A82"/>
+            <a:srgbClr val="33415C"/>
           </a:solidFill>
           <a:ln/>
         </p:spPr>
@@ -4130,13 +4130,13 @@
         <p:spPr>
           <a:xfrm>
             <a:off x="0" y="1051560"/>
-            <a:ext cx="12192000" cy="64008"/>
-          </a:xfrm>
-          <a:prstGeom prst="rect">
-            <a:avLst/>
-          </a:prstGeom>
-          <a:solidFill>
-            <a:srgbClr val="1C7293"/>
+            <a:ext cx="12192000" cy="45720"/>
+          </a:xfrm>
+          <a:prstGeom prst="rect">
+            <a:avLst/>
+          </a:prstGeom>
+          <a:solidFill>
+            <a:srgbClr val="C9A227"/>
           </a:solidFill>
           <a:ln/>
         </p:spPr>
@@ -4204,7 +4204,7 @@
             <a:r>
               <a:rPr lang="en-US" sz="1200" dirty="0">
                 <a:solidFill>
-                  <a:srgbClr val="CADCFC"/>
+                  <a:srgbClr val="D8DCE4"/>
                 </a:solidFill>
               </a:rPr>
               <a:t>gating fails the build - audit informs triage</a:t>
@@ -4234,7 +4234,7 @@
           </a:solidFill>
           <a:ln w="25400">
             <a:solidFill>
-              <a:srgbClr val="00A896"/>
+              <a:srgbClr val="3A7D44"/>
             </a:solidFill>
             <a:prstDash val="solid"/>
           </a:ln>
@@ -4267,7 +4267,7 @@
             <a:r>
               <a:rPr lang="en-US" sz="1500" b="1" dirty="0">
                 <a:solidFill>
-                  <a:srgbClr val="00A896"/>
+                  <a:srgbClr val="3A7D44"/>
                 </a:solidFill>
               </a:rPr>
               <a:t>GATING</a:t>
@@ -4307,7 +4307,7 @@
             <a:r>
               <a:rPr lang="en-US" sz="1250" dirty="0">
                 <a:solidFill>
-                  <a:srgbClr val="1B2A41"/>
+                  <a:srgbClr val="232A33"/>
                 </a:solidFill>
               </a:rPr>
               <a:t>Semgrep Kimai taint ruleset - 0 findings / 1047 files</a:t>
@@ -4325,7 +4325,7 @@
             <a:r>
               <a:rPr lang="en-US" sz="1250" dirty="0">
                 <a:solidFill>
-                  <a:srgbClr val="1B2A41"/>
+                  <a:srgbClr val="232A33"/>
                 </a:solidFill>
               </a:rPr>
               <a:t>PHPStan level 9 (src + tests)</a:t>
@@ -4343,7 +4343,7 @@
             <a:r>
               <a:rPr lang="en-US" sz="1250" dirty="0">
                 <a:solidFill>
-                  <a:srgbClr val="1B2A41"/>
+                  <a:srgbClr val="232A33"/>
                 </a:solidFill>
               </a:rPr>
               <a:t>composer audit + pnpm audit - clean</a:t>
@@ -4361,7 +4361,7 @@
             <a:r>
               <a:rPr lang="en-US" sz="1250" dirty="0">
                 <a:solidFill>
-                  <a:srgbClr val="1B2A41"/>
+                  <a:srgbClr val="232A33"/>
                 </a:solidFill>
               </a:rPr>
               <a:t>Trivy vulnerabilities + secrets (HIGH/CRITICAL)</a:t>
@@ -4391,7 +4391,7 @@
           </a:solidFill>
           <a:ln w="25400">
             <a:solidFill>
-              <a:srgbClr val="1C7293"/>
+              <a:srgbClr val="5D6B7A"/>
             </a:solidFill>
             <a:prstDash val="solid"/>
           </a:ln>
@@ -4424,7 +4424,7 @@
             <a:r>
               <a:rPr lang="en-US" sz="1500" b="1" dirty="0">
                 <a:solidFill>
-                  <a:srgbClr val="1C7293"/>
+                  <a:srgbClr val="5D6B7A"/>
                 </a:solidFill>
               </a:rPr>
               <a:t>AUDIT (reported, no hard fail)</a:t>
@@ -4464,7 +4464,7 @@
             <a:r>
               <a:rPr lang="en-US" sz="1250" dirty="0">
                 <a:solidFill>
-                  <a:srgbClr val="1B2A41"/>
+                  <a:srgbClr val="232A33"/>
                 </a:solidFill>
               </a:rPr>
               <a:t>Semgrep p/php + p/security-audit packs</a:t>
@@ -4482,7 +4482,7 @@
             <a:r>
               <a:rPr lang="en-US" sz="1250" dirty="0">
                 <a:solidFill>
-                  <a:srgbClr val="1B2A41"/>
+                  <a:srgbClr val="232A33"/>
                 </a:solidFill>
               </a:rPr>
               <a:t>Trivy misconfig: 3 HIGH in upstream Dockerfile (no USER, no --no-install-recommends) - triaged</a:t>
@@ -4500,7 +4500,7 @@
             <a:r>
               <a:rPr lang="en-US" sz="1250" dirty="0">
                 <a:solidFill>
-                  <a:srgbClr val="1B2A41"/>
+                  <a:srgbClr val="232A33"/>
                 </a:solidFill>
               </a:rPr>
               <a:t>OWASP Dependency-Check (experimental PHP analyzer)</a:t>
@@ -4524,13 +4524,13 @@
             <a:avLst/>
           </a:prstGeom>
           <a:solidFill>
-            <a:srgbClr val="CADCFC">
+            <a:srgbClr val="D8DCE4">
               <a:alpha val="45000"/>
             </a:srgbClr>
           </a:solidFill>
           <a:ln w="12700">
             <a:solidFill>
-              <a:srgbClr val="065A82"/>
+              <a:srgbClr val="33415C"/>
             </a:solidFill>
             <a:prstDash val="dash"/>
           </a:ln>
@@ -4563,7 +4563,7 @@
             <a:r>
               <a:rPr lang="en-US" sz="1000" i="1" dirty="0">
                 <a:solidFill>
-                  <a:srgbClr val="065A82"/>
+                  <a:srgbClr val="33415C"/>
                 </a:solidFill>
               </a:rPr>
               <a:t>[insert: semgrep scan / composer audit terminal]</a:t>
@@ -4612,7 +4612,7 @@
             <a:avLst/>
           </a:prstGeom>
           <a:solidFill>
-            <a:srgbClr val="F4F7FB"/>
+            <a:srgbClr val="F6F6F3"/>
           </a:solidFill>
           <a:ln/>
         </p:spPr>
@@ -4632,7 +4632,7 @@
             <a:avLst/>
           </a:prstGeom>
           <a:solidFill>
-            <a:srgbClr val="065A82"/>
+            <a:srgbClr val="33415C"/>
           </a:solidFill>
           <a:ln/>
         </p:spPr>
@@ -4646,13 +4646,13 @@
         <p:spPr>
           <a:xfrm>
             <a:off x="0" y="1051560"/>
-            <a:ext cx="12192000" cy="64008"/>
-          </a:xfrm>
-          <a:prstGeom prst="rect">
-            <a:avLst/>
-          </a:prstGeom>
-          <a:solidFill>
-            <a:srgbClr val="1C7293"/>
+            <a:ext cx="12192000" cy="45720"/>
+          </a:xfrm>
+          <a:prstGeom prst="rect">
+            <a:avLst/>
+          </a:prstGeom>
+          <a:solidFill>
+            <a:srgbClr val="C9A227"/>
           </a:solidFill>
           <a:ln/>
         </p:spPr>
@@ -4720,7 +4720,7 @@
             <a:r>
               <a:rPr lang="en-US" sz="1200" dirty="0">
                 <a:solidFill>
-                  <a:srgbClr val="CADCFC"/>
+                  <a:srgbClr val="D8DCE4"/>
                 </a:solidFill>
               </a:rPr>
               <a:t>deploy.sh: certs - persistent secrets - build - compose - migrations - readiness</a:t>
@@ -4746,7 +4746,7 @@
             </a:avLst>
           </a:prstGeom>
           <a:solidFill>
-            <a:srgbClr val="065A82"/>
+            <a:srgbClr val="33415C"/>
           </a:solidFill>
           <a:ln/>
         </p:spPr>
@@ -4814,7 +4814,7 @@
             <a:r>
               <a:rPr lang="en-US" sz="1000" dirty="0">
                 <a:solidFill>
-                  <a:srgbClr val="CADCFC"/>
+                  <a:srgbClr val="D8DCE4"/>
                 </a:solidFill>
               </a:rPr>
               <a:t>TLS 1.2/1.3, HSTS, headers, rate limit</a:t>
@@ -4838,7 +4838,7 @@
             <a:avLst/>
           </a:prstGeom>
           <a:solidFill>
-            <a:srgbClr val="1C7293"/>
+            <a:srgbClr val="5D6B7A"/>
           </a:solidFill>
           <a:ln/>
         </p:spPr>
@@ -4860,7 +4860,7 @@
             </a:avLst>
           </a:prstGeom>
           <a:solidFill>
-            <a:srgbClr val="065A82"/>
+            <a:srgbClr val="33415C"/>
           </a:solidFill>
           <a:ln/>
         </p:spPr>
@@ -4928,7 +4928,7 @@
             <a:r>
               <a:rPr lang="en-US" sz="1000" dirty="0">
                 <a:solidFill>
-                  <a:srgbClr val="CADCFC"/>
+                  <a:srgbClr val="D8DCE4"/>
                 </a:solidFill>
               </a:rPr>
               <a:t>Apache+PHP, APP_DEBUG=0</a:t>
@@ -4952,7 +4952,7 @@
             <a:avLst/>
           </a:prstGeom>
           <a:solidFill>
-            <a:srgbClr val="1C7293"/>
+            <a:srgbClr val="5D6B7A"/>
           </a:solidFill>
           <a:ln/>
         </p:spPr>
@@ -4974,7 +4974,7 @@
             </a:avLst>
           </a:prstGeom>
           <a:solidFill>
-            <a:srgbClr val="065A82"/>
+            <a:srgbClr val="33415C"/>
           </a:solidFill>
           <a:ln/>
         </p:spPr>
@@ -5042,7 +5042,7 @@
             <a:r>
               <a:rPr lang="en-US" sz="1000" dirty="0">
                 <a:solidFill>
-                  <a:srgbClr val="CADCFC"/>
+                  <a:srgbClr val="D8DCE4"/>
                 </a:solidFill>
               </a:rPr>
               <a:t>internal network only</a:t>
@@ -5082,7 +5082,7 @@
             <a:r>
               <a:rPr lang="en-US" sz="1300" dirty="0">
                 <a:solidFill>
-                  <a:srgbClr val="1B2A41"/>
+                  <a:srgbClr val="232A33"/>
                 </a:solidFill>
               </a:rPr>
               <a:t>Hardening: no-new-privileges, read-only nginx + minimal caps, sensitive-path denies, login rate limiting</a:t>
@@ -5100,7 +5100,7 @@
             <a:r>
               <a:rPr lang="en-US" sz="1300" dirty="0">
                 <a:solidFill>
-                  <a:srgbClr val="1B2A41"/>
+                  <a:srgbClr val="232A33"/>
                 </a:solidFill>
               </a:rPr>
               <a:t>Secrets: random per environment, persisted off the CI-wiped checkout (/opt/kimai/devsecops-deploy)</a:t>
@@ -5118,7 +5118,7 @@
             <a:r>
               <a:rPr lang="en-US" sz="1300" dirty="0">
                 <a:solidFill>
-                  <a:srgbClr val="1B2A41"/>
+                  <a:srgbClr val="232A33"/>
                 </a:solidFill>
               </a:rPr>
               <a:t>CSP in Report-Only mode - deliberate trade-off for inline frontend assets</a:t>
@@ -5142,13 +5142,13 @@
             <a:avLst/>
           </a:prstGeom>
           <a:solidFill>
-            <a:srgbClr val="CADCFC">
+            <a:srgbClr val="D8DCE4">
               <a:alpha val="45000"/>
             </a:srgbClr>
           </a:solidFill>
           <a:ln w="12700">
             <a:solidFill>
-              <a:srgbClr val="065A82"/>
+              <a:srgbClr val="33415C"/>
             </a:solidFill>
             <a:prstDash val="dash"/>
           </a:ln>
@@ -5181,7 +5181,7 @@
             <a:r>
               <a:rPr lang="en-US" sz="1000" i="1" dirty="0">
                 <a:solidFill>
-                  <a:srgbClr val="065A82"/>
+                  <a:srgbClr val="33415C"/>
                 </a:solidFill>
               </a:rPr>
               <a:t>[insert: Deployment finished + browser login at https://localhost:8443]</a:t>
@@ -5230,7 +5230,7 @@
             <a:avLst/>
           </a:prstGeom>
           <a:solidFill>
-            <a:srgbClr val="F4F7FB"/>
+            <a:srgbClr val="F6F6F3"/>
           </a:solidFill>
           <a:ln/>
         </p:spPr>
@@ -5250,7 +5250,7 @@
             <a:avLst/>
           </a:prstGeom>
           <a:solidFill>
-            <a:srgbClr val="065A82"/>
+            <a:srgbClr val="33415C"/>
           </a:solidFill>
           <a:ln/>
         </p:spPr>
@@ -5264,13 +5264,13 @@
         <p:spPr>
           <a:xfrm>
             <a:off x="0" y="1051560"/>
-            <a:ext cx="12192000" cy="64008"/>
-          </a:xfrm>
-          <a:prstGeom prst="rect">
-            <a:avLst/>
-          </a:prstGeom>
-          <a:solidFill>
-            <a:srgbClr val="1C7293"/>
+            <a:ext cx="12192000" cy="45720"/>
+          </a:xfrm>
+          <a:prstGeom prst="rect">
+            <a:avLst/>
+          </a:prstGeom>
+          <a:solidFill>
+            <a:srgbClr val="C9A227"/>
           </a:solidFill>
           <a:ln/>
         </p:spPr>
@@ -5338,7 +5338,7 @@
             <a:r>
               <a:rPr lang="en-US" sz="1200" dirty="0">
                 <a:solidFill>
-                  <a:srgbClr val="CADCFC"/>
+                  <a:srgbClr val="D8DCE4"/>
                 </a:solidFill>
               </a:rPr>
               <a:t>automated checks gate every deployment</a:t>
@@ -5368,7 +5368,7 @@
           </a:solidFill>
           <a:ln w="25400">
             <a:solidFill>
-              <a:srgbClr val="00A896"/>
+              <a:srgbClr val="3A7D44"/>
             </a:solidFill>
             <a:prstDash val="solid"/>
           </a:ln>
@@ -5401,7 +5401,7 @@
             <a:r>
               <a:rPr lang="en-US" sz="3600" b="1" dirty="0">
                 <a:solidFill>
-                  <a:srgbClr val="00A896"/>
+                  <a:srgbClr val="3A7D44"/>
                 </a:solidFill>
               </a:rPr>
               <a:t>4/4</a:t>
@@ -5437,7 +5437,7 @@
             <a:r>
               <a:rPr lang="en-US" sz="1100" dirty="0">
                 <a:solidFill>
-                  <a:srgbClr val="1B2A41"/>
+                  <a:srgbClr val="232A33"/>
                 </a:solidFill>
               </a:rPr>
               <a:t>smoke test PASS</a:t>
@@ -5467,7 +5467,7 @@
           </a:solidFill>
           <a:ln w="25400">
             <a:solidFill>
-              <a:srgbClr val="00A896"/>
+              <a:srgbClr val="3A7D44"/>
             </a:solidFill>
             <a:prstDash val="solid"/>
           </a:ln>
@@ -5500,7 +5500,7 @@
             <a:r>
               <a:rPr lang="en-US" sz="3600" b="1" dirty="0">
                 <a:solidFill>
-                  <a:srgbClr val="00A896"/>
+                  <a:srgbClr val="3A7D44"/>
                 </a:solidFill>
               </a:rPr>
               <a:t>22/22</a:t>
@@ -5536,7 +5536,7 @@
             <a:r>
               <a:rPr lang="en-US" sz="1100" dirty="0">
                 <a:solidFill>
-                  <a:srgbClr val="1B2A41"/>
+                  <a:srgbClr val="232A33"/>
                 </a:solidFill>
               </a:rPr>
               <a:t>config audit PASS</a:t>
@@ -5566,7 +5566,7 @@
           </a:solidFill>
           <a:ln w="25400">
             <a:solidFill>
-              <a:srgbClr val="00A896"/>
+              <a:srgbClr val="3A7D44"/>
             </a:solidFill>
             <a:prstDash val="solid"/>
           </a:ln>
@@ -5599,7 +5599,7 @@
             <a:r>
               <a:rPr lang="en-US" sz="3600" b="1" dirty="0">
                 <a:solidFill>
-                  <a:srgbClr val="00A896"/>
+                  <a:srgbClr val="3A7D44"/>
                 </a:solidFill>
               </a:rPr>
               <a:t>ZAP</a:t>
@@ -5635,7 +5635,7 @@
             <a:r>
               <a:rPr lang="en-US" sz="1100" dirty="0">
                 <a:solidFill>
-                  <a:srgbClr val="1B2A41"/>
+                  <a:srgbClr val="232A33"/>
                 </a:solidFill>
               </a:rPr>
               <a:t>baseline PASS</a:t>
@@ -5665,7 +5665,7 @@
           </a:solidFill>
           <a:ln w="25400">
             <a:solidFill>
-              <a:srgbClr val="00A896"/>
+              <a:srgbClr val="3A7D44"/>
             </a:solidFill>
             <a:prstDash val="solid"/>
           </a:ln>
@@ -5698,7 +5698,7 @@
             <a:r>
               <a:rPr lang="en-US" sz="3600" b="1" dirty="0">
                 <a:solidFill>
-                  <a:srgbClr val="00A896"/>
+                  <a:srgbClr val="3A7D44"/>
                 </a:solidFill>
               </a:rPr>
               <a:t>0</a:t>
@@ -5734,7 +5734,7 @@
             <a:r>
               <a:rPr lang="en-US" sz="1100" dirty="0">
                 <a:solidFill>
-                  <a:srgbClr val="1B2A41"/>
+                  <a:srgbClr val="232A33"/>
                 </a:solidFill>
               </a:rPr>
               <a:t>HIGH/CRITICAL in lockfiles</a:t>
@@ -5774,7 +5774,7 @@
             <a:r>
               <a:rPr lang="en-US" sz="1300" dirty="0">
                 <a:solidFill>
-                  <a:srgbClr val="1B2A41"/>
+                  <a:srgbClr val="232A33"/>
                 </a:solidFill>
               </a:rPr>
               <a:t>smoke: HTTPS 200, content marker, HTTP-&gt;HTTPS 301, API 401 unauthenticated</a:t>
@@ -5792,7 +5792,7 @@
             <a:r>
               <a:rPr lang="en-US" sz="1300" dirty="0">
                 <a:solidFill>
-                  <a:srgbClr val="1B2A41"/>
+                  <a:srgbClr val="232A33"/>
                 </a:solidFill>
               </a:rPr>
               <a:t>audit: HSTS, cookie flags incl. Secure, TLS 1.0/1.1 rejected, TRACE 405, sensitive paths blocked, no debug leakage</a:t>
@@ -5810,7 +5810,7 @@
             <a:r>
               <a:rPr lang="en-US" sz="1300" dirty="0">
                 <a:solidFill>
-                  <a:srgbClr val="1B2A41"/>
+                  <a:srgbClr val="232A33"/>
                 </a:solidFill>
               </a:rPr>
               <a:t>OWASP ZAP baseline passive DAST - FAIL alerts gate the build</a:t>
@@ -5834,13 +5834,13 @@
             <a:avLst/>
           </a:prstGeom>
           <a:solidFill>
-            <a:srgbClr val="CADCFC">
+            <a:srgbClr val="D8DCE4">
               <a:alpha val="45000"/>
             </a:srgbClr>
           </a:solidFill>
           <a:ln w="12700">
             <a:solidFill>
-              <a:srgbClr val="065A82"/>
+              <a:srgbClr val="33415C"/>
             </a:solidFill>
             <a:prstDash val="dash"/>
           </a:ln>
@@ -5873,7 +5873,7 @@
             <a:r>
               <a:rPr lang="en-US" sz="1000" i="1" dirty="0">
                 <a:solidFill>
-                  <a:srgbClr val="065A82"/>
+                  <a:srgbClr val="33415C"/>
                 </a:solidFill>
               </a:rPr>
               <a:t>[insert: smoke-test + security-audit PASS output]</a:t>
@@ -5922,7 +5922,7 @@
             <a:avLst/>
           </a:prstGeom>
           <a:solidFill>
-            <a:srgbClr val="F4F7FB"/>
+            <a:srgbClr val="F6F6F3"/>
           </a:solidFill>
           <a:ln/>
         </p:spPr>
@@ -5942,7 +5942,7 @@
             <a:avLst/>
           </a:prstGeom>
           <a:solidFill>
-            <a:srgbClr val="065A82"/>
+            <a:srgbClr val="33415C"/>
           </a:solidFill>
           <a:ln/>
         </p:spPr>
@@ -5956,13 +5956,13 @@
         <p:spPr>
           <a:xfrm>
             <a:off x="0" y="1051560"/>
-            <a:ext cx="12192000" cy="64008"/>
-          </a:xfrm>
-          <a:prstGeom prst="rect">
-            <a:avLst/>
-          </a:prstGeom>
-          <a:solidFill>
-            <a:srgbClr val="1C7293"/>
+            <a:ext cx="12192000" cy="45720"/>
+          </a:xfrm>
+          <a:prstGeom prst="rect">
+            <a:avLst/>
+          </a:prstGeom>
+          <a:solidFill>
+            <a:srgbClr val="C9A227"/>
           </a:solidFill>
           <a:ln/>
         </p:spPr>
@@ -6030,7 +6030,7 @@
             <a:r>
               <a:rPr lang="en-US" sz="1200" dirty="0">
                 <a:solidFill>
-                  <a:srgbClr val="CADCFC"/>
+                  <a:srgbClr val="D8DCE4"/>
                 </a:solidFill>
               </a:rPr>
               <a:t>private advisory - PoC - triage - regression-tested fix</a:t>
@@ -6060,7 +6060,7 @@
           </a:solidFill>
           <a:ln w="25400">
             <a:solidFill>
-              <a:srgbClr val="F96167"/>
+              <a:srgbClr val="9E2B25"/>
             </a:solidFill>
             <a:prstDash val="solid"/>
           </a:ln>
@@ -6093,7 +6093,7 @@
             <a:r>
               <a:rPr lang="en-US" sz="1500" b="1" dirty="0">
                 <a:solidFill>
-                  <a:srgbClr val="F96167"/>
+                  <a:srgbClr val="9E2B25"/>
                 </a:solidFill>
               </a:rPr>
               <a:t>GHSA-pvc4-crg3-gj44 (triaged)</a:t>
@@ -6133,7 +6133,7 @@
             <a:r>
               <a:rPr lang="en-US" sz="1200" dirty="0">
                 <a:solidFill>
-                  <a:srgbClr val="1B2A41"/>
+                  <a:srgbClr val="232A33"/>
                 </a:solidFill>
               </a:rPr>
               <a:t>Missing authorization on project view export - any ROLE_USER could download the project overview XLSX</a:t>
@@ -6151,7 +6151,7 @@
             <a:r>
               <a:rPr lang="en-US" sz="1200" dirty="0">
                 <a:solidFill>
-                  <a:srgbClr val="1B2A41"/>
+                  <a:srgbClr val="232A33"/>
                 </a:solidFill>
               </a:rPr>
               <a:t>Root cause: method-level guards instead of class-level (only reporting controller structured that way)</a:t>
@@ -6169,7 +6169,7 @@
             <a:r>
               <a:rPr lang="en-US" sz="1200" dirty="0">
                 <a:solidFill>
-                  <a:srgbClr val="1B2A41"/>
+                  <a:srgbClr val="232A33"/>
                 </a:solidFill>
               </a:rPr>
               <a:t>Fix: both IsGranted attributes moved to class level + 4 regression tests (verified failing without the fix)</a:t>
@@ -6199,7 +6199,7 @@
           </a:solidFill>
           <a:ln w="19050">
             <a:solidFill>
-              <a:srgbClr val="1C7293"/>
+              <a:srgbClr val="C9A227"/>
             </a:solidFill>
             <a:prstDash val="solid"/>
           </a:ln>
@@ -6232,7 +6232,7 @@
             <a:r>
               <a:rPr lang="en-US" sz="1400" b="1" dirty="0">
                 <a:solidFill>
-                  <a:srgbClr val="1C7293"/>
+                  <a:srgbClr val="C9A227"/>
                 </a:solidFill>
               </a:rPr>
               <a:t>Lesson learned</a:t>
@@ -6268,7 +6268,7 @@
             <a:r>
               <a:rPr lang="en-US" sz="1150" dirty="0">
                 <a:solidFill>
-                  <a:srgbClr val="1B2A41"/>
+                  <a:srgbClr val="232A33"/>
                 </a:solidFill>
               </a:rPr>
               <a:t>GHSA-pjrx-mwv9-j9vf was rejected: documented behavior, super-admin-only by default. Verify the documented threat model before filing.</a:t>
@@ -6292,13 +6292,13 @@
             <a:avLst/>
           </a:prstGeom>
           <a:solidFill>
-            <a:srgbClr val="CADCFC">
+            <a:srgbClr val="D8DCE4">
               <a:alpha val="45000"/>
             </a:srgbClr>
           </a:solidFill>
           <a:ln w="12700">
             <a:solidFill>
-              <a:srgbClr val="065A82"/>
+              <a:srgbClr val="33415C"/>
             </a:solidFill>
             <a:prstDash val="dash"/>
           </a:ln>
@@ -6331,7 +6331,7 @@
             <a:r>
               <a:rPr lang="en-US" sz="1000" i="1" dirty="0">
                 <a:solidFill>
-                  <a:srgbClr val="065A82"/>
+                  <a:srgbClr val="33415C"/>
                 </a:solidFill>
               </a:rPr>
               <a:t>[insert: advisory thread (redacted) + fix PR with green checks]</a:t>
@@ -6380,7 +6380,7 @@
             <a:avLst/>
           </a:prstGeom>
           <a:solidFill>
-            <a:srgbClr val="F4F7FB"/>
+            <a:srgbClr val="F6F6F3"/>
           </a:solidFill>
           <a:ln/>
         </p:spPr>
@@ -6400,7 +6400,7 @@
             <a:avLst/>
           </a:prstGeom>
           <a:solidFill>
-            <a:srgbClr val="065A82"/>
+            <a:srgbClr val="33415C"/>
           </a:solidFill>
           <a:ln/>
         </p:spPr>
@@ -6414,13 +6414,13 @@
         <p:spPr>
           <a:xfrm>
             <a:off x="0" y="1051560"/>
-            <a:ext cx="12192000" cy="64008"/>
-          </a:xfrm>
-          <a:prstGeom prst="rect">
-            <a:avLst/>
-          </a:prstGeom>
-          <a:solidFill>
-            <a:srgbClr val="1C7293"/>
+            <a:ext cx="12192000" cy="45720"/>
+          </a:xfrm>
+          <a:prstGeom prst="rect">
+            <a:avLst/>
+          </a:prstGeom>
+          <a:solidFill>
+            <a:srgbClr val="C9A227"/>
           </a:solidFill>
           <a:ln/>
         </p:spPr>
@@ -6488,7 +6488,7 @@
             <a:r>
               <a:rPr lang="en-US" sz="1200" dirty="0">
                 <a:solidFill>
-                  <a:srgbClr val="CADCFC"/>
+                  <a:srgbClr val="D8DCE4"/>
                 </a:solidFill>
               </a:rPr>
               <a:t>built so the maintainers can adopt it unchanged</a:t>
@@ -6518,7 +6518,7 @@
           </a:solidFill>
           <a:ln w="19050">
             <a:solidFill>
-              <a:srgbClr val="065A82"/>
+              <a:srgbClr val="33415C"/>
             </a:solidFill>
             <a:prstDash val="solid"/>
           </a:ln>
@@ -6551,7 +6551,7 @@
             <a:r>
               <a:rPr lang="en-US" sz="1400" b="1" dirty="0">
                 <a:solidFill>
-                  <a:srgbClr val="065A82"/>
+                  <a:srgbClr val="33415C"/>
                 </a:solidFill>
               </a:rPr>
               <a:t>Notification flow</a:t>
@@ -6591,7 +6591,7 @@
             <a:r>
               <a:rPr lang="en-US" sz="1050" dirty="0">
                 <a:solidFill>
-                  <a:srgbClr val="1B2A41"/>
+                  <a:srgbClr val="232A33"/>
                 </a:solidFill>
               </a:rPr>
               <a:t>failure or finding -&gt; notify job</a:t>
@@ -6609,7 +6609,7 @@
             <a:r>
               <a:rPr lang="en-US" sz="1050" dirty="0">
                 <a:solidFill>
-                  <a:srgbClr val="1B2A41"/>
+                  <a:srgbClr val="232A33"/>
                 </a:solidFill>
               </a:rPr>
               <a:t>search open 'devsecops' issues first</a:t>
@@ -6627,7 +6627,7 @@
             <a:r>
               <a:rPr lang="en-US" sz="1050" dirty="0">
                 <a:solidFill>
-                  <a:srgbClr val="1B2A41"/>
+                  <a:srgbClr val="232A33"/>
                 </a:solidFill>
               </a:rPr>
               <a:t>comment on existing issue (de-dupe)</a:t>
@@ -6645,7 +6645,7 @@
             <a:r>
               <a:rPr lang="en-US" sz="1050" dirty="0">
                 <a:solidFill>
-                  <a:srgbClr val="1B2A41"/>
+                  <a:srgbClr val="232A33"/>
                 </a:solidFill>
               </a:rPr>
               <a:t>otherwise create labeled issue</a:t>
@@ -6663,7 +6663,7 @@
             <a:r>
               <a:rPr lang="en-US" sz="1050" dirty="0">
                 <a:solidFill>
-                  <a:srgbClr val="1B2A41"/>
+                  <a:srgbClr val="232A33"/>
                 </a:solidFill>
               </a:rPr>
               <a:t>optional Slack/Discord webhook</a:t>
@@ -6693,7 +6693,7 @@
           </a:solidFill>
           <a:ln w="19050">
             <a:solidFill>
-              <a:srgbClr val="00A896"/>
+              <a:srgbClr val="3A7D44"/>
             </a:solidFill>
             <a:prstDash val="solid"/>
           </a:ln>
@@ -6726,7 +6726,7 @@
             <a:r>
               <a:rPr lang="en-US" sz="1400" b="1" dirty="0">
                 <a:solidFill>
-                  <a:srgbClr val="065A82"/>
+                  <a:srgbClr val="33415C"/>
                 </a:solidFill>
               </a:rPr>
               <a:t>Reuse story</a:t>
@@ -6766,7 +6766,7 @@
             <a:r>
               <a:rPr lang="en-US" sz="1050" dirty="0">
                 <a:solidFill>
-                  <a:srgbClr val="1B2A41"/>
+                  <a:srgbClr val="232A33"/>
                 </a:solidFill>
               </a:rPr>
               <a:t>SAST identical to upstream linting.yaml</a:t>
@@ -6784,7 +6784,7 @@
             <a:r>
               <a:rPr lang="en-US" sz="1050" dirty="0">
                 <a:solidFill>
-                  <a:srgbClr val="1B2A41"/>
+                  <a:srgbClr val="232A33"/>
                 </a:solidFill>
               </a:rPr>
               <a:t>same MariaDB service + test bootstrap as testing.yaml</a:t>
@@ -6802,7 +6802,7 @@
             <a:r>
               <a:rPr lang="en-US" sz="1050" dirty="0">
                 <a:solidFill>
-                  <a:srgbClr val="1B2A41"/>
+                  <a:srgbClr val="232A33"/>
                 </a:solidFill>
               </a:rPr>
               <a:t>deployment uses the repository Dockerfile</a:t>
@@ -6820,7 +6820,7 @@
             <a:r>
               <a:rPr lang="en-US" sz="1050" dirty="0">
                 <a:solidFill>
-                  <a:srgbClr val="1B2A41"/>
+                  <a:srgbClr val="232A33"/>
                 </a:solidFill>
               </a:rPr>
               <a:t>regression tests inside existing test classes</a:t>
@@ -6838,7 +6838,7 @@
             <a:r>
               <a:rPr lang="en-US" sz="1050" dirty="0">
                 <a:solidFill>
-                  <a:srgbClr val="1B2A41"/>
+                  <a:srgbClr val="232A33"/>
                 </a:solidFill>
               </a:rPr>
               <a:t>tests run via the project's composer scripts</a:t>
@@ -6862,13 +6862,13 @@
             <a:avLst/>
           </a:prstGeom>
           <a:solidFill>
-            <a:srgbClr val="CADCFC">
+            <a:srgbClr val="D8DCE4">
               <a:alpha val="45000"/>
             </a:srgbClr>
           </a:solidFill>
           <a:ln w="12700">
             <a:solidFill>
-              <a:srgbClr val="065A82"/>
+              <a:srgbClr val="33415C"/>
             </a:solidFill>
             <a:prstDash val="dash"/>
           </a:ln>
@@ -6901,7 +6901,7 @@
             <a:r>
               <a:rPr lang="en-US" sz="1000" i="1" dirty="0">
                 <a:solidFill>
-                  <a:srgbClr val="065A82"/>
+                  <a:srgbClr val="33415C"/>
                 </a:solidFill>
               </a:rPr>
               <a:t>[insert: notification issue + maintainer/reuse evidence (redacted)]</a:t>
@@ -6950,7 +6950,7 @@
             <a:avLst/>
           </a:prstGeom>
           <a:solidFill>
-            <a:srgbClr val="21295C"/>
+            <a:srgbClr val="1F2A44"/>
           </a:solidFill>
           <a:ln/>
         </p:spPr>
@@ -7000,13 +7000,13 @@
         <p:spPr>
           <a:xfrm>
             <a:off x="0" y="1325880"/>
-            <a:ext cx="12192000" cy="64008"/>
-          </a:xfrm>
-          <a:prstGeom prst="rect">
-            <a:avLst/>
-          </a:prstGeom>
-          <a:solidFill>
-            <a:srgbClr val="1C7293"/>
+            <a:ext cx="12192000" cy="45720"/>
+          </a:xfrm>
+          <a:prstGeom prst="rect">
+            <a:avLst/>
+          </a:prstGeom>
+          <a:solidFill>
+            <a:srgbClr val="C9A227"/>
           </a:solidFill>
           <a:ln/>
         </p:spPr>
@@ -7042,7 +7042,7 @@
             <a:r>
               <a:rPr lang="en-US" sz="1500" dirty="0">
                 <a:solidFill>
-                  <a:srgbClr val="CADCFC"/>
+                  <a:srgbClr val="D8DCE4"/>
                 </a:solidFill>
               </a:rPr>
               <a:t>Gating security rules need ~zero false positives - one Semgrep false positive triaged and annotated</a:t>
@@ -7060,7 +7060,7 @@
             <a:r>
               <a:rPr lang="en-US" sz="1500" dirty="0">
                 <a:solidFill>
-                  <a:srgbClr val="CADCFC"/>
+                  <a:srgbClr val="D8DCE4"/>
                 </a:solidFill>
               </a:rPr>
               <a:t>Gating vs audit: Trivy misconfig must inform, not hard-fail (upstream Dockerfile findings)</a:t>
@@ -7078,7 +7078,7 @@
             <a:r>
               <a:rPr lang="en-US" sz="1500" dirty="0">
                 <a:solidFill>
-                  <a:srgbClr val="CADCFC"/>
+                  <a:srgbClr val="D8DCE4"/>
                 </a:solidFill>
               </a:rPr>
               <a:t>Pipelines are hardened against their real environment - six runner failure classes found via live logs and fixed</a:t>
@@ -7096,7 +7096,7 @@
             <a:r>
               <a:rPr lang="en-US" sz="1500" dirty="0">
                 <a:solidFill>
-                  <a:srgbClr val="CADCFC"/>
+                  <a:srgbClr val="D8DCE4"/>
                 </a:solidFill>
               </a:rPr>
               <a:t>Read the documented threat model before filing (rejected advisory)</a:t>
@@ -7114,7 +7114,7 @@
             <a:r>
               <a:rPr lang="en-US" sz="1500" dirty="0">
                 <a:solidFill>
-                  <a:srgbClr val="CADCFC"/>
+                  <a:srgbClr val="D8DCE4"/>
                 </a:solidFill>
               </a:rPr>
               <a:t>Reuse beats novelty: upstream conventions made every review conversation easy</a:t>
@@ -7144,7 +7144,7 @@
           </a:solidFill>
           <a:ln w="25400">
             <a:solidFill>
-              <a:srgbClr val="00A896"/>
+              <a:srgbClr val="3A7D44"/>
             </a:solidFill>
             <a:prstDash val="solid"/>
           </a:ln>
@@ -7177,7 +7177,7 @@
             <a:r>
               <a:rPr lang="en-US" sz="3600" b="1" dirty="0">
                 <a:solidFill>
-                  <a:srgbClr val="00A896"/>
+                  <a:srgbClr val="3A7D44"/>
                 </a:solidFill>
               </a:rPr>
               <a:t>100%</a:t>
@@ -7213,7 +7213,7 @@
             <a:r>
               <a:rPr lang="en-US" sz="1100" dirty="0">
                 <a:solidFill>
-                  <a:srgbClr val="1B2A41"/>
+                  <a:srgbClr val="232A33"/>
                 </a:solidFill>
               </a:rPr>
               <a:t>on-premise</a:t>
@@ -7243,7 +7243,7 @@
           </a:solidFill>
           <a:ln w="25400">
             <a:solidFill>
-              <a:srgbClr val="00A896"/>
+              <a:srgbClr val="3A7D44"/>
             </a:solidFill>
             <a:prstDash val="solid"/>
           </a:ln>
@@ -7276,7 +7276,7 @@
             <a:r>
               <a:rPr lang="en-US" sz="3600" b="1" dirty="0">
                 <a:solidFill>
-                  <a:srgbClr val="00A896"/>
+                  <a:srgbClr val="3A7D44"/>
                 </a:solidFill>
               </a:rPr>
               <a:t>32</a:t>
@@ -7312,7 +7312,7 @@
             <a:r>
               <a:rPr lang="en-US" sz="1100" dirty="0">
                 <a:solidFill>
-                  <a:srgbClr val="1B2A41"/>
+                  <a:srgbClr val="232A33"/>
                 </a:solidFill>
               </a:rPr>
               <a:t>WSTG tests green</a:t>
@@ -7342,7 +7342,7 @@
           </a:solidFill>
           <a:ln w="25400">
             <a:solidFill>
-              <a:srgbClr val="00A896"/>
+              <a:srgbClr val="3A7D44"/>
             </a:solidFill>
             <a:prstDash val="solid"/>
           </a:ln>
@@ -7375,7 +7375,7 @@
             <a:r>
               <a:rPr lang="en-US" sz="3600" b="1" dirty="0">
                 <a:solidFill>
-                  <a:srgbClr val="00A896"/>
+                  <a:srgbClr val="3A7D44"/>
                 </a:solidFill>
               </a:rPr>
               <a:t>22/22</a:t>
@@ -7411,7 +7411,7 @@
             <a:r>
               <a:rPr lang="en-US" sz="1100" dirty="0">
                 <a:solidFill>
-                  <a:srgbClr val="1B2A41"/>
+                  <a:srgbClr val="232A33"/>
                 </a:solidFill>
               </a:rPr>
               <a:t>hardening checks</a:t>
@@ -7441,7 +7441,7 @@
           </a:solidFill>
           <a:ln w="25400">
             <a:solidFill>
-              <a:srgbClr val="F96167"/>
+              <a:srgbClr val="9E2B25"/>
             </a:solidFill>
             <a:prstDash val="solid"/>
           </a:ln>
@@ -7474,7 +7474,7 @@
             <a:r>
               <a:rPr lang="en-US" sz="3600" b="1" dirty="0">
                 <a:solidFill>
-                  <a:srgbClr val="F96167"/>
+                  <a:srgbClr val="9E2B25"/>
                 </a:solidFill>
               </a:rPr>
               <a:t>1</a:t>
@@ -7510,7 +7510,7 @@
             <a:r>
               <a:rPr lang="en-US" sz="1100" dirty="0">
                 <a:solidFill>
-                  <a:srgbClr val="1B2A41"/>
+                  <a:srgbClr val="232A33"/>
                 </a:solidFill>
               </a:rPr>
               <a:t>triaged bug + fix</a:t>
@@ -7546,7 +7546,7 @@
             <a:r>
               <a:rPr lang="en-US" sz="1200" dirty="0">
                 <a:solidFill>
-                  <a:srgbClr val="CADCFC"/>
+                  <a:srgbClr val="D8DCE4"/>
                 </a:solidFill>
               </a:rPr>
               <a:t>Future: enforcing CSP, authenticated ZAP scans, SAML/LDAP coverage, promote audit scanners to gating</a:t>

</xml_diff>

<commit_message>
Add Group 1 roster, course and instructor to deliverables
Title page of the report and the deck's title slide now carry
Application Security Methodology, Group 1 (Abdul-Ramon Adeyemi Folarin,
Immanuel Guarin, Sherman Law, Suranjit Paul) and Instructor Mark Shtern,
plus a note that bug reports and videos are individual submissions.

Co-authored-by: Adeyemi Folarin <devzephyr@users.noreply.github.com>
</commit_message>
<xml_diff>
--- a/devsecops/deliverables/DevSecOps_Slides.pptx
+++ b/devsecops/deliverables/DevSecOps_Slides.pptx
@@ -510,7 +510,7 @@
           <a:p>
             <a:r>
               <a:rPr lang="en-US" dirty="0"/>
-              <a:t>Introduce yourself, the application and why DevSecOps. Point at the four stats: they frame the whole talk. ~1 min.</a:t>
+              <a:t>Introduce yourself, the application and why DevSecOps. Point at the four stats: they frame the whole talk. Each member records their own video of the same length; bug reports are individual submissions. ~1 min.</a:t>
             </a:r>
             <a:endParaRPr lang="en-US" dirty="0"/>
           </a:p>
@@ -2132,8 +2132,8 @@
         </p:nvSpPr>
         <p:spPr>
           <a:xfrm>
-            <a:off x="731520" y="5577840"/>
-            <a:ext cx="8229600" cy="365760"/>
+            <a:off x="731520" y="5532120"/>
+            <a:ext cx="10515600" cy="365760"/>
           </a:xfrm>
           <a:prstGeom prst="rect">
             <a:avLst/>
@@ -2154,7 +2154,7 @@
                   <a:srgbClr val="FFFFFF"/>
                 </a:solidFill>
               </a:rPr>
-              <a:t>&lt;Your name&gt;  |  &lt;course&gt;  |  &lt;date&gt;</a:t>
+              <a:t>Group 1: Abdul-Ramon Adeyemi Folarin  ·  Immanuel Guarin  ·  Sherman Law  ·  Suranjit Paul</a:t>
             </a:r>
             <a:endParaRPr lang="en-US" sz="1400" dirty="0"/>
           </a:p>
@@ -2168,7 +2168,43 @@
         </p:nvSpPr>
         <p:spPr>
           <a:xfrm>
-            <a:off x="731520" y="5989320"/>
+            <a:off x="731520" y="5897880"/>
+            <a:ext cx="9144000" cy="320040"/>
+          </a:xfrm>
+          <a:prstGeom prst="rect">
+            <a:avLst/>
+          </a:prstGeom>
+          <a:noFill/>
+          <a:ln/>
+        </p:spPr>
+        <p:txBody>
+          <a:bodyPr wrap="square" lIns="0" tIns="0" rIns="0" bIns="0" rtlCol="0" anchor="ctr"/>
+          <a:lstStyle/>
+          <a:p>
+            <a:pPr indent="0" marL="0">
+              <a:buNone/>
+            </a:pPr>
+            <a:r>
+              <a:rPr lang="en-US" sz="1200" dirty="0">
+                <a:solidFill>
+                  <a:srgbClr val="D8DCE4"/>
+                </a:solidFill>
+              </a:rPr>
+              <a:t>Application Security Methodology  |  Instructor: Mark Shtern  |  August 2026</a:t>
+            </a:r>
+            <a:endParaRPr lang="en-US" sz="1200" dirty="0"/>
+          </a:p>
+        </p:txBody>
+      </p:sp>
+      <p:sp>
+        <p:nvSpPr>
+          <p:cNvPr id="21" name="Text 19"/>
+          <p:cNvSpPr/>
+          <p:nvPr/>
+        </p:nvSpPr>
+        <p:spPr>
+          <a:xfrm>
+            <a:off x="731520" y="6217920"/>
             <a:ext cx="9144000" cy="320040"/>
           </a:xfrm>
           <a:prstGeom prst="rect">

</xml_diff>